<commit_message>
Optimize all sections for mobile
- Navbar: smaller logo on mobile (h-16), responsive navbar height
- Hero: min-h-85vh on mobile, smaller text, compact CTAs, pt for navbar
- Services: smaller cards, touch-friendly consultar buttons with bg
- Gallery: touch swipe support in lightbox, counter, col-span-2 on mobile
- Testimonials: horizontal scroll with snap on mobile
- Locations: shorter map on mobile, compact padding
- All sections: reduced vertical padding on mobile (py-16)
- Layout: viewport-fit=cover, theme-color meta
- CSS: scrollbar-hide utility for horizontal scroll sections
- Lightbox: larger touch targets, swipe left/right navigation

Co-Authored-By: Claude Opus 4.6 <noreply@anthropic.com>
</commit_message>
<xml_diff>
--- a/PresentacionRomo.pptx
+++ b/PresentacionRomo.pptx
@@ -17,9 +17,10 @@
     <p:sldId id="265" r:id="rId11"/>
     <p:sldId id="266" r:id="rId12"/>
     <p:sldId id="267" r:id="rId13"/>
+    <p:sldId id="268" r:id="rId14"/>
   </p:sldIdLst>
   <p:notesMasterIdLst>
-    <p:notesMasterId r:id="rId14"/>
+    <p:notesMasterId r:id="rId15"/>
   </p:notesMasterIdLst>
   <p:sldSz cx="9144000" cy="5143500"/>
   <p:notesSz cx="5143500" cy="9144000"/>
@@ -801,6 +802,94 @@
             <a:fld id="{F7021451-1387-4CA6-816F-3879F97B5CBC}" type="slidenum">
               <a:rPr lang="en-US"/>
               <a:t>12</a:t>
+            </a:fld>
+            <a:endParaRPr lang="en-US"/>
+          </a:p>
+        </p:txBody>
+      </p:sp>
+    </p:spTree>
+    <p:extLst>
+      <p:ext uri="{BB962C8B-B14F-4D97-AF65-F5344CB8AC3E}">
+        <p14:creationId xmlns:p14="http://schemas.microsoft.com/office/powerpoint/2010/main" val="1024086991"/>
+      </p:ext>
+    </p:extLst>
+  </p:cSld>
+  <p:clrMapOvr>
+    <a:masterClrMapping/>
+  </p:clrMapOvr>
+</p:notes>
+</file>
+
+<file path=ppt/notesSlides/notesSlide13.xml><?xml version="1.0" encoding="utf-8"?>
+<p:notes xmlns:a="http://schemas.openxmlformats.org/drawingml/2006/main" xmlns:r="http://schemas.openxmlformats.org/officeDocument/2006/relationships" xmlns:p="http://schemas.openxmlformats.org/presentationml/2006/main">
+  <p:cSld>
+    <p:spTree>
+      <p:nvGrpSpPr>
+        <p:cNvPr id="1" name=""/>
+        <p:cNvGrpSpPr/>
+        <p:nvPr/>
+      </p:nvGrpSpPr>
+      <p:grpSpPr>
+        <a:xfrm>
+          <a:off x="0" y="0"/>
+          <a:ext cx="0" cy="0"/>
+          <a:chOff x="0" y="0"/>
+          <a:chExt cx="0" cy="0"/>
+        </a:xfrm>
+      </p:grpSpPr>
+      <p:sp>
+        <p:nvSpPr>
+          <p:cNvPr id="2" name="Slide Image Placeholder 1"/>
+          <p:cNvSpPr>
+            <a:spLocks noGrp="1" noRot="1" noChangeAspect="1"/>
+          </p:cNvSpPr>
+          <p:nvPr>
+            <p:ph type="sldImg"/>
+          </p:nvPr>
+        </p:nvSpPr>
+        <p:spPr/>
+      </p:sp>
+      <p:sp>
+        <p:nvSpPr>
+          <p:cNvPr id="3" name="Notes Placeholder 2"/>
+          <p:cNvSpPr>
+            <a:spLocks noGrp="1"/>
+          </p:cNvSpPr>
+          <p:nvPr>
+            <p:ph type="body" idx="1"/>
+          </p:nvPr>
+        </p:nvSpPr>
+        <p:spPr/>
+        <p:txBody>
+          <a:bodyPr/>
+          <a:lstStyle/>
+          <a:p>
+            <a:r>
+              <a:rPr lang="en-US" dirty="0"/>
+              <a:t/>
+            </a:r>
+            <a:endParaRPr lang="en-US" dirty="0"/>
+          </a:p>
+        </p:txBody>
+      </p:sp>
+      <p:sp>
+        <p:nvSpPr>
+          <p:cNvPr id="4" name="Slide Number Placeholder 3"/>
+          <p:cNvSpPr>
+            <a:spLocks noGrp="1"/>
+          </p:cNvSpPr>
+          <p:nvPr>
+            <p:ph type="sldNum" sz="quarter" idx="10"/>
+          </p:nvPr>
+        </p:nvSpPr>
+        <p:spPr/>
+        <p:txBody>
+          <a:bodyPr/>
+          <a:lstStyle/>
+          <a:p>
+            <a:fld id="{F7021451-1387-4CA6-816F-3879F97B5CBC}" type="slidenum">
+              <a:rPr lang="en-US"/>
+              <a:t>13</a:t>
             </a:fld>
             <a:endParaRPr lang="en-US"/>
           </a:p>
@@ -2859,7 +2948,7 @@
                 <a:ea typeface="Arial Black" pitchFamily="34" charset="-122"/>
                 <a:cs typeface="Arial Black" pitchFamily="34" charset="-120"/>
               </a:rPr>
-              <a:t>USD 150</a:t>
+              <a:t>USD 300</a:t>
             </a:r>
             <a:endParaRPr lang="en-US" sz="2800" dirty="0"/>
           </a:p>
@@ -2957,7 +3046,7 @@
                 <a:ea typeface="Arial Black" pitchFamily="34" charset="-122"/>
                 <a:cs typeface="Arial Black" pitchFamily="34" charset="-120"/>
               </a:rPr>
-              <a:t>USD 50/mes</a:t>
+              <a:t>USD 100/mes</a:t>
             </a:r>
             <a:endParaRPr lang="en-US" sz="1600" dirty="0"/>
           </a:p>
@@ -3398,7 +3487,7 @@
                 <a:ea typeface="Arial Black" pitchFamily="34" charset="-122"/>
                 <a:cs typeface="Arial Black" pitchFamily="34" charset="-120"/>
               </a:rPr>
-              <a:t>USD 300</a:t>
+              <a:t>USD 600</a:t>
             </a:r>
             <a:endParaRPr lang="en-US" sz="2800" dirty="0"/>
           </a:p>
@@ -3496,7 +3585,7 @@
                 <a:ea typeface="Arial Black" pitchFamily="34" charset="-122"/>
                 <a:cs typeface="Arial Black" pitchFamily="34" charset="-120"/>
               </a:rPr>
-              <a:t>USD 100/mes</a:t>
+              <a:t>USD 200/mes</a:t>
             </a:r>
             <a:endParaRPr lang="en-US" sz="1600" dirty="0"/>
           </a:p>
@@ -4004,7 +4093,7 @@
                 <a:ea typeface="Arial Black" pitchFamily="34" charset="-122"/>
                 <a:cs typeface="Arial Black" pitchFamily="34" charset="-120"/>
               </a:rPr>
-              <a:t>USD 450</a:t>
+              <a:t>USD 900</a:t>
             </a:r>
             <a:endParaRPr lang="en-US" sz="2800" dirty="0"/>
           </a:p>
@@ -4102,7 +4191,7 @@
                 <a:ea typeface="Arial Black" pitchFamily="34" charset="-122"/>
                 <a:cs typeface="Arial Black" pitchFamily="34" charset="-120"/>
               </a:rPr>
-              <a:t>USD 150/mes</a:t>
+              <a:t>USD 300/mes</a:t>
             </a:r>
             <a:endParaRPr lang="en-US" sz="1600" dirty="0"/>
           </a:p>
@@ -4519,7 +4608,7 @@
                 <a:ea typeface="Arial" pitchFamily="34" charset="-122"/>
                 <a:cs typeface="Arial" pitchFamily="34" charset="-120"/>
               </a:rPr>
-              <a:t>Sin contratos. Cancelás cuando quieras. Garantía de satisfacción 30 días.</a:t>
+              <a:t>Compromiso mínimo 3 meses. Después seguís mes a mes. Garantía de satisfacción.</a:t>
             </a:r>
             <a:endParaRPr lang="en-US" sz="1100" dirty="0"/>
           </a:p>
@@ -4536,6 +4625,978 @@
 <file path=ppt/slides/slide12.xml><?xml version="1.0" encoding="utf-8"?>
 <p:sld xmlns:a="http://schemas.openxmlformats.org/drawingml/2006/main" xmlns:r="http://schemas.openxmlformats.org/officeDocument/2006/relationships" xmlns:p="http://schemas.openxmlformats.org/presentationml/2006/main">
   <p:cSld name="Slide 12">
+    <p:bg>
+      <p:bgPr>
+        <a:solidFill>
+          <a:srgbClr val="0A0A0A"/>
+        </a:solidFill>
+      </p:bgPr>
+    </p:bg>
+    <p:spTree>
+      <p:nvGrpSpPr>
+        <p:cNvPr id="1" name=""/>
+        <p:cNvGrpSpPr/>
+        <p:nvPr/>
+      </p:nvGrpSpPr>
+      <p:grpSpPr>
+        <a:xfrm>
+          <a:off x="0" y="0"/>
+          <a:ext cx="0" cy="0"/>
+          <a:chOff x="0" y="0"/>
+          <a:chExt cx="0" cy="0"/>
+        </a:xfrm>
+      </p:grpSpPr>
+      <p:sp>
+        <p:nvSpPr>
+          <p:cNvPr id="2" name="Text 0"/>
+          <p:cNvSpPr/>
+          <p:nvPr/>
+        </p:nvSpPr>
+        <p:spPr>
+          <a:xfrm>
+            <a:off x="457200" y="182880"/>
+            <a:ext cx="8229600" cy="548640"/>
+          </a:xfrm>
+          <a:prstGeom prst="rect">
+            <a:avLst/>
+          </a:prstGeom>
+          <a:noFill/>
+          <a:ln/>
+        </p:spPr>
+        <p:txBody>
+          <a:bodyPr wrap="square" lIns="0" tIns="0" rIns="0" bIns="0" rtlCol="0" anchor="ctr"/>
+          <a:lstStyle/>
+          <a:p>
+            <a:pPr indent="0" marL="0">
+              <a:buNone/>
+            </a:pPr>
+            <a:r>
+              <a:rPr lang="en-US" sz="2800" b="1" dirty="0">
+                <a:solidFill>
+                  <a:srgbClr val="FFFFFF"/>
+                </a:solidFill>
+                <a:latin typeface="Arial Black" pitchFamily="34" charset="0"/>
+                <a:ea typeface="Arial Black" pitchFamily="34" charset="-122"/>
+                <a:cs typeface="Arial Black" pitchFamily="34" charset="-120"/>
+              </a:rPr>
+              <a:t>¿CÓMO SE PAGA?</a:t>
+            </a:r>
+            <a:endParaRPr lang="en-US" sz="2800" dirty="0"/>
+          </a:p>
+        </p:txBody>
+      </p:sp>
+      <p:sp>
+        <p:nvSpPr>
+          <p:cNvPr id="3" name="Text 1"/>
+          <p:cNvSpPr/>
+          <p:nvPr/>
+        </p:nvSpPr>
+        <p:spPr>
+          <a:xfrm>
+            <a:off x="457200" y="914400"/>
+            <a:ext cx="4114800" cy="365760"/>
+          </a:xfrm>
+          <a:prstGeom prst="rect">
+            <a:avLst/>
+          </a:prstGeom>
+          <a:noFill/>
+          <a:ln/>
+        </p:spPr>
+        <p:txBody>
+          <a:bodyPr wrap="square" lIns="0" tIns="0" rIns="0" bIns="0" rtlCol="0" anchor="ctr"/>
+          <a:lstStyle/>
+          <a:p>
+            <a:pPr indent="0" marL="0">
+              <a:buNone/>
+            </a:pPr>
+            <a:r>
+              <a:rPr lang="en-US" sz="1600" b="1" dirty="0">
+                <a:solidFill>
+                  <a:srgbClr val="25D366"/>
+                </a:solidFill>
+                <a:latin typeface="Arial Black" pitchFamily="34" charset="0"/>
+                <a:ea typeface="Arial Black" pitchFamily="34" charset="-122"/>
+                <a:cs typeface="Arial Black" pitchFamily="34" charset="-120"/>
+              </a:rPr>
+              <a:t>ESTRUCTURA DE PAGO</a:t>
+            </a:r>
+            <a:endParaRPr lang="en-US" sz="1600" dirty="0"/>
+          </a:p>
+        </p:txBody>
+      </p:sp>
+      <p:sp>
+        <p:nvSpPr>
+          <p:cNvPr id="4" name="Shape 2"/>
+          <p:cNvSpPr/>
+          <p:nvPr/>
+        </p:nvSpPr>
+        <p:spPr>
+          <a:xfrm>
+            <a:off x="457200" y="1463040"/>
+            <a:ext cx="457200" cy="457200"/>
+          </a:xfrm>
+          <a:prstGeom prst="ellipse">
+            <a:avLst/>
+          </a:prstGeom>
+          <a:solidFill>
+            <a:srgbClr val="25D366"/>
+          </a:solidFill>
+          <a:ln/>
+        </p:spPr>
+      </p:sp>
+      <p:sp>
+        <p:nvSpPr>
+          <p:cNvPr id="5" name="Text 3"/>
+          <p:cNvSpPr/>
+          <p:nvPr/>
+        </p:nvSpPr>
+        <p:spPr>
+          <a:xfrm>
+            <a:off x="457200" y="1463040"/>
+            <a:ext cx="457200" cy="457200"/>
+          </a:xfrm>
+          <a:prstGeom prst="rect">
+            <a:avLst/>
+          </a:prstGeom>
+          <a:noFill/>
+          <a:ln/>
+        </p:spPr>
+        <p:txBody>
+          <a:bodyPr wrap="square" lIns="0" tIns="0" rIns="0" bIns="0" rtlCol="0" anchor="ctr"/>
+          <a:lstStyle/>
+          <a:p>
+            <a:pPr algn="ctr" indent="0" marL="0">
+              <a:buNone/>
+            </a:pPr>
+            <a:r>
+              <a:rPr lang="en-US" sz="1800" b="1" dirty="0">
+                <a:solidFill>
+                  <a:srgbClr val="FFFFFF"/>
+                </a:solidFill>
+                <a:latin typeface="Arial Black" pitchFamily="34" charset="0"/>
+                <a:ea typeface="Arial Black" pitchFamily="34" charset="-122"/>
+                <a:cs typeface="Arial Black" pitchFamily="34" charset="-120"/>
+              </a:rPr>
+              <a:t>1</a:t>
+            </a:r>
+            <a:endParaRPr lang="en-US" sz="1800" dirty="0"/>
+          </a:p>
+        </p:txBody>
+      </p:sp>
+      <p:sp>
+        <p:nvSpPr>
+          <p:cNvPr id="6" name="Text 4"/>
+          <p:cNvSpPr/>
+          <p:nvPr/>
+        </p:nvSpPr>
+        <p:spPr>
+          <a:xfrm>
+            <a:off x="1097280" y="1417320"/>
+            <a:ext cx="3474720" cy="320040"/>
+          </a:xfrm>
+          <a:prstGeom prst="rect">
+            <a:avLst/>
+          </a:prstGeom>
+          <a:noFill/>
+          <a:ln/>
+        </p:spPr>
+        <p:txBody>
+          <a:bodyPr wrap="square" lIns="0" tIns="0" rIns="0" bIns="0" rtlCol="0" anchor="ctr"/>
+          <a:lstStyle/>
+          <a:p>
+            <a:pPr indent="0" marL="0">
+              <a:buNone/>
+            </a:pPr>
+            <a:r>
+              <a:rPr lang="en-US" sz="1400" b="1" dirty="0">
+                <a:solidFill>
+                  <a:srgbClr val="FFFFFF"/>
+                </a:solidFill>
+                <a:latin typeface="Arial Black" pitchFamily="34" charset="0"/>
+                <a:ea typeface="Arial Black" pitchFamily="34" charset="-122"/>
+                <a:cs typeface="Arial Black" pitchFamily="34" charset="-120"/>
+              </a:rPr>
+              <a:t>Setup único al confirmar</a:t>
+            </a:r>
+            <a:endParaRPr lang="en-US" sz="1400" dirty="0"/>
+          </a:p>
+        </p:txBody>
+      </p:sp>
+      <p:sp>
+        <p:nvSpPr>
+          <p:cNvPr id="7" name="Text 5"/>
+          <p:cNvSpPr/>
+          <p:nvPr/>
+        </p:nvSpPr>
+        <p:spPr>
+          <a:xfrm>
+            <a:off x="1097280" y="1737360"/>
+            <a:ext cx="3474720" cy="502920"/>
+          </a:xfrm>
+          <a:prstGeom prst="rect">
+            <a:avLst/>
+          </a:prstGeom>
+          <a:noFill/>
+          <a:ln/>
+        </p:spPr>
+        <p:txBody>
+          <a:bodyPr wrap="square" lIns="0" tIns="0" rIns="0" bIns="0" rtlCol="0" anchor="ctr"/>
+          <a:lstStyle/>
+          <a:p>
+            <a:pPr indent="0" marL="0">
+              <a:buNone/>
+            </a:pPr>
+            <a:r>
+              <a:rPr lang="en-US" sz="1100" dirty="0">
+                <a:solidFill>
+                  <a:srgbClr val="B0B0B0"/>
+                </a:solidFill>
+                <a:latin typeface="Arial" pitchFamily="34" charset="0"/>
+                <a:ea typeface="Arial" pitchFamily="34" charset="-122"/>
+                <a:cs typeface="Arial" pitchFamily="34" charset="-120"/>
+              </a:rPr>
+              <a:t>Pagás el setup y arrancamos a trabajar. En 7 días tenés todo funcionando.</a:t>
+            </a:r>
+            <a:endParaRPr lang="en-US" sz="1100" dirty="0"/>
+          </a:p>
+        </p:txBody>
+      </p:sp>
+      <p:sp>
+        <p:nvSpPr>
+          <p:cNvPr id="8" name="Shape 6"/>
+          <p:cNvSpPr/>
+          <p:nvPr/>
+        </p:nvSpPr>
+        <p:spPr>
+          <a:xfrm>
+            <a:off x="667512" y="1920240"/>
+            <a:ext cx="36576" cy="594360"/>
+          </a:xfrm>
+          <a:prstGeom prst="rect">
+            <a:avLst/>
+          </a:prstGeom>
+          <a:solidFill>
+            <a:srgbClr val="2A2A2A"/>
+          </a:solidFill>
+          <a:ln/>
+        </p:spPr>
+      </p:sp>
+      <p:sp>
+        <p:nvSpPr>
+          <p:cNvPr id="9" name="Shape 7"/>
+          <p:cNvSpPr/>
+          <p:nvPr/>
+        </p:nvSpPr>
+        <p:spPr>
+          <a:xfrm>
+            <a:off x="457200" y="2514600"/>
+            <a:ext cx="457200" cy="457200"/>
+          </a:xfrm>
+          <a:prstGeom prst="ellipse">
+            <a:avLst/>
+          </a:prstGeom>
+          <a:solidFill>
+            <a:srgbClr val="FF6D00"/>
+          </a:solidFill>
+          <a:ln/>
+        </p:spPr>
+      </p:sp>
+      <p:sp>
+        <p:nvSpPr>
+          <p:cNvPr id="10" name="Text 8"/>
+          <p:cNvSpPr/>
+          <p:nvPr/>
+        </p:nvSpPr>
+        <p:spPr>
+          <a:xfrm>
+            <a:off x="457200" y="2514600"/>
+            <a:ext cx="457200" cy="457200"/>
+          </a:xfrm>
+          <a:prstGeom prst="rect">
+            <a:avLst/>
+          </a:prstGeom>
+          <a:noFill/>
+          <a:ln/>
+        </p:spPr>
+        <p:txBody>
+          <a:bodyPr wrap="square" lIns="0" tIns="0" rIns="0" bIns="0" rtlCol="0" anchor="ctr"/>
+          <a:lstStyle/>
+          <a:p>
+            <a:pPr algn="ctr" indent="0" marL="0">
+              <a:buNone/>
+            </a:pPr>
+            <a:r>
+              <a:rPr lang="en-US" sz="1800" b="1" dirty="0">
+                <a:solidFill>
+                  <a:srgbClr val="FFFFFF"/>
+                </a:solidFill>
+                <a:latin typeface="Arial Black" pitchFamily="34" charset="0"/>
+                <a:ea typeface="Arial Black" pitchFamily="34" charset="-122"/>
+                <a:cs typeface="Arial Black" pitchFamily="34" charset="-120"/>
+              </a:rPr>
+              <a:t>2</a:t>
+            </a:r>
+            <a:endParaRPr lang="en-US" sz="1800" dirty="0"/>
+          </a:p>
+        </p:txBody>
+      </p:sp>
+      <p:sp>
+        <p:nvSpPr>
+          <p:cNvPr id="11" name="Text 9"/>
+          <p:cNvSpPr/>
+          <p:nvPr/>
+        </p:nvSpPr>
+        <p:spPr>
+          <a:xfrm>
+            <a:off x="1097280" y="2468880"/>
+            <a:ext cx="3474720" cy="320040"/>
+          </a:xfrm>
+          <a:prstGeom prst="rect">
+            <a:avLst/>
+          </a:prstGeom>
+          <a:noFill/>
+          <a:ln/>
+        </p:spPr>
+        <p:txBody>
+          <a:bodyPr wrap="square" lIns="0" tIns="0" rIns="0" bIns="0" rtlCol="0" anchor="ctr"/>
+          <a:lstStyle/>
+          <a:p>
+            <a:pPr indent="0" marL="0">
+              <a:buNone/>
+            </a:pPr>
+            <a:r>
+              <a:rPr lang="en-US" sz="1400" b="1" dirty="0">
+                <a:solidFill>
+                  <a:srgbClr val="FFFFFF"/>
+                </a:solidFill>
+                <a:latin typeface="Arial Black" pitchFamily="34" charset="0"/>
+                <a:ea typeface="Arial Black" pitchFamily="34" charset="-122"/>
+                <a:cs typeface="Arial Black" pitchFamily="34" charset="-120"/>
+              </a:rPr>
+              <a:t>Cuota mensual desde el mes 1</a:t>
+            </a:r>
+            <a:endParaRPr lang="en-US" sz="1400" dirty="0"/>
+          </a:p>
+        </p:txBody>
+      </p:sp>
+      <p:sp>
+        <p:nvSpPr>
+          <p:cNvPr id="12" name="Text 10"/>
+          <p:cNvSpPr/>
+          <p:nvPr/>
+        </p:nvSpPr>
+        <p:spPr>
+          <a:xfrm>
+            <a:off x="1097280" y="2788920"/>
+            <a:ext cx="3474720" cy="502920"/>
+          </a:xfrm>
+          <a:prstGeom prst="rect">
+            <a:avLst/>
+          </a:prstGeom>
+          <a:noFill/>
+          <a:ln/>
+        </p:spPr>
+        <p:txBody>
+          <a:bodyPr wrap="square" lIns="0" tIns="0" rIns="0" bIns="0" rtlCol="0" anchor="ctr"/>
+          <a:lstStyle/>
+          <a:p>
+            <a:pPr indent="0" marL="0">
+              <a:buNone/>
+            </a:pPr>
+            <a:r>
+              <a:rPr lang="en-US" sz="1100" dirty="0">
+                <a:solidFill>
+                  <a:srgbClr val="B0B0B0"/>
+                </a:solidFill>
+                <a:latin typeface="Arial" pitchFamily="34" charset="0"/>
+                <a:ea typeface="Arial" pitchFamily="34" charset="-122"/>
+                <a:cs typeface="Arial" pitchFamily="34" charset="-120"/>
+              </a:rPr>
+              <a:t>Se paga por adelantado cada mes. El primer mes arranca cuando tu página esté online.</a:t>
+            </a:r>
+            <a:endParaRPr lang="en-US" sz="1100" dirty="0"/>
+          </a:p>
+        </p:txBody>
+      </p:sp>
+      <p:sp>
+        <p:nvSpPr>
+          <p:cNvPr id="13" name="Shape 11"/>
+          <p:cNvSpPr/>
+          <p:nvPr/>
+        </p:nvSpPr>
+        <p:spPr>
+          <a:xfrm>
+            <a:off x="667512" y="2971800"/>
+            <a:ext cx="36576" cy="594360"/>
+          </a:xfrm>
+          <a:prstGeom prst="rect">
+            <a:avLst/>
+          </a:prstGeom>
+          <a:solidFill>
+            <a:srgbClr val="2A2A2A"/>
+          </a:solidFill>
+          <a:ln/>
+        </p:spPr>
+      </p:sp>
+      <p:sp>
+        <p:nvSpPr>
+          <p:cNvPr id="14" name="Shape 12"/>
+          <p:cNvSpPr/>
+          <p:nvPr/>
+        </p:nvSpPr>
+        <p:spPr>
+          <a:xfrm>
+            <a:off x="457200" y="3566160"/>
+            <a:ext cx="457200" cy="457200"/>
+          </a:xfrm>
+          <a:prstGeom prst="ellipse">
+            <a:avLst/>
+          </a:prstGeom>
+          <a:solidFill>
+            <a:srgbClr val="FFB300"/>
+          </a:solidFill>
+          <a:ln/>
+        </p:spPr>
+      </p:sp>
+      <p:sp>
+        <p:nvSpPr>
+          <p:cNvPr id="15" name="Text 13"/>
+          <p:cNvSpPr/>
+          <p:nvPr/>
+        </p:nvSpPr>
+        <p:spPr>
+          <a:xfrm>
+            <a:off x="457200" y="3566160"/>
+            <a:ext cx="457200" cy="457200"/>
+          </a:xfrm>
+          <a:prstGeom prst="rect">
+            <a:avLst/>
+          </a:prstGeom>
+          <a:noFill/>
+          <a:ln/>
+        </p:spPr>
+        <p:txBody>
+          <a:bodyPr wrap="square" lIns="0" tIns="0" rIns="0" bIns="0" rtlCol="0" anchor="ctr"/>
+          <a:lstStyle/>
+          <a:p>
+            <a:pPr algn="ctr" indent="0" marL="0">
+              <a:buNone/>
+            </a:pPr>
+            <a:r>
+              <a:rPr lang="en-US" sz="1800" b="1" dirty="0">
+                <a:solidFill>
+                  <a:srgbClr val="FFFFFF"/>
+                </a:solidFill>
+                <a:latin typeface="Arial Black" pitchFamily="34" charset="0"/>
+                <a:ea typeface="Arial Black" pitchFamily="34" charset="-122"/>
+                <a:cs typeface="Arial Black" pitchFamily="34" charset="-120"/>
+              </a:rPr>
+              <a:t>3</a:t>
+            </a:r>
+            <a:endParaRPr lang="en-US" sz="1800" dirty="0"/>
+          </a:p>
+        </p:txBody>
+      </p:sp>
+      <p:sp>
+        <p:nvSpPr>
+          <p:cNvPr id="16" name="Text 14"/>
+          <p:cNvSpPr/>
+          <p:nvPr/>
+        </p:nvSpPr>
+        <p:spPr>
+          <a:xfrm>
+            <a:off x="1097280" y="3520440"/>
+            <a:ext cx="3474720" cy="320040"/>
+          </a:xfrm>
+          <a:prstGeom prst="rect">
+            <a:avLst/>
+          </a:prstGeom>
+          <a:noFill/>
+          <a:ln/>
+        </p:spPr>
+        <p:txBody>
+          <a:bodyPr wrap="square" lIns="0" tIns="0" rIns="0" bIns="0" rtlCol="0" anchor="ctr"/>
+          <a:lstStyle/>
+          <a:p>
+            <a:pPr indent="0" marL="0">
+              <a:buNone/>
+            </a:pPr>
+            <a:r>
+              <a:rPr lang="en-US" sz="1400" b="1" dirty="0">
+                <a:solidFill>
+                  <a:srgbClr val="FFFFFF"/>
+                </a:solidFill>
+                <a:latin typeface="Arial Black" pitchFamily="34" charset="0"/>
+                <a:ea typeface="Arial Black" pitchFamily="34" charset="-122"/>
+                <a:cs typeface="Arial Black" pitchFamily="34" charset="-120"/>
+              </a:rPr>
+              <a:t>Compromiso mínimo: 3 meses</a:t>
+            </a:r>
+            <a:endParaRPr lang="en-US" sz="1400" dirty="0"/>
+          </a:p>
+        </p:txBody>
+      </p:sp>
+      <p:sp>
+        <p:nvSpPr>
+          <p:cNvPr id="17" name="Text 15"/>
+          <p:cNvSpPr/>
+          <p:nvPr/>
+        </p:nvSpPr>
+        <p:spPr>
+          <a:xfrm>
+            <a:off x="1097280" y="3840480"/>
+            <a:ext cx="3474720" cy="502920"/>
+          </a:xfrm>
+          <a:prstGeom prst="rect">
+            <a:avLst/>
+          </a:prstGeom>
+          <a:noFill/>
+          <a:ln/>
+        </p:spPr>
+        <p:txBody>
+          <a:bodyPr wrap="square" lIns="0" tIns="0" rIns="0" bIns="0" rtlCol="0" anchor="ctr"/>
+          <a:lstStyle/>
+          <a:p>
+            <a:pPr indent="0" marL="0">
+              <a:buNone/>
+            </a:pPr>
+            <a:r>
+              <a:rPr lang="en-US" sz="1100" dirty="0">
+                <a:solidFill>
+                  <a:srgbClr val="B0B0B0"/>
+                </a:solidFill>
+                <a:latin typeface="Arial" pitchFamily="34" charset="0"/>
+                <a:ea typeface="Arial" pitchFamily="34" charset="-122"/>
+                <a:cs typeface="Arial" pitchFamily="34" charset="-120"/>
+              </a:rPr>
+              <a:t>Es el tiempo mínimo para ver resultados reales. Después, seguís mes a mes sin permanencia.</a:t>
+            </a:r>
+            <a:endParaRPr lang="en-US" sz="1100" dirty="0"/>
+          </a:p>
+        </p:txBody>
+      </p:sp>
+      <p:sp>
+        <p:nvSpPr>
+          <p:cNvPr id="18" name="Shape 16"/>
+          <p:cNvSpPr/>
+          <p:nvPr/>
+        </p:nvSpPr>
+        <p:spPr>
+          <a:xfrm>
+            <a:off x="4846320" y="914400"/>
+            <a:ext cx="3931920" cy="3291840"/>
+          </a:xfrm>
+          <a:prstGeom prst="rect">
+            <a:avLst/>
+          </a:prstGeom>
+          <a:solidFill>
+            <a:srgbClr val="161616"/>
+          </a:solidFill>
+          <a:ln w="12700">
+            <a:solidFill>
+              <a:srgbClr val="2A2A2A"/>
+            </a:solidFill>
+            <a:prstDash val="solid"/>
+          </a:ln>
+          <a:effectLst>
+            <a:outerShdw sx="100000" sy="100000" kx="0" ky="0" algn="bl" rotWithShape="0" blurRad="76200" dist="25400" dir="8100000">
+              <a:srgbClr val="000000">
+                <a:alpha val="30000"/>
+              </a:srgbClr>
+            </a:outerShdw>
+          </a:effectLst>
+        </p:spPr>
+      </p:sp>
+      <p:sp>
+        <p:nvSpPr>
+          <p:cNvPr id="19" name="Shape 17"/>
+          <p:cNvSpPr/>
+          <p:nvPr/>
+        </p:nvSpPr>
+        <p:spPr>
+          <a:xfrm>
+            <a:off x="4846320" y="914400"/>
+            <a:ext cx="3931920" cy="54864"/>
+          </a:xfrm>
+          <a:prstGeom prst="rect">
+            <a:avLst/>
+          </a:prstGeom>
+          <a:solidFill>
+            <a:srgbClr val="FFB300"/>
+          </a:solidFill>
+          <a:ln/>
+        </p:spPr>
+      </p:sp>
+      <p:sp>
+        <p:nvSpPr>
+          <p:cNvPr id="20" name="Text 18"/>
+          <p:cNvSpPr/>
+          <p:nvPr/>
+        </p:nvSpPr>
+        <p:spPr>
+          <a:xfrm>
+            <a:off x="5029200" y="1097280"/>
+            <a:ext cx="3566160" cy="365760"/>
+          </a:xfrm>
+          <a:prstGeom prst="rect">
+            <a:avLst/>
+          </a:prstGeom>
+          <a:noFill/>
+          <a:ln/>
+        </p:spPr>
+        <p:txBody>
+          <a:bodyPr wrap="square" lIns="0" tIns="0" rIns="0" bIns="0" rtlCol="0" anchor="ctr"/>
+          <a:lstStyle/>
+          <a:p>
+            <a:pPr indent="0" marL="0">
+              <a:buNone/>
+            </a:pPr>
+            <a:r>
+              <a:rPr lang="en-US" sz="1600" b="1" dirty="0">
+                <a:solidFill>
+                  <a:srgbClr val="FFB300"/>
+                </a:solidFill>
+                <a:latin typeface="Arial Black" pitchFamily="34" charset="0"/>
+                <a:ea typeface="Arial Black" pitchFamily="34" charset="-122"/>
+                <a:cs typeface="Arial Black" pitchFamily="34" charset="-120"/>
+              </a:rPr>
+              <a:t>MÉTODOS DE PAGO</a:t>
+            </a:r>
+            <a:endParaRPr lang="en-US" sz="1600" dirty="0"/>
+          </a:p>
+        </p:txBody>
+      </p:sp>
+      <p:sp>
+        <p:nvSpPr>
+          <p:cNvPr id="21" name="Shape 19"/>
+          <p:cNvSpPr/>
+          <p:nvPr/>
+        </p:nvSpPr>
+        <p:spPr>
+          <a:xfrm>
+            <a:off x="5029200" y="1691640"/>
+            <a:ext cx="3566160" cy="548640"/>
+          </a:xfrm>
+          <a:prstGeom prst="rect">
+            <a:avLst/>
+          </a:prstGeom>
+          <a:solidFill>
+            <a:srgbClr val="1E1E1E"/>
+          </a:solidFill>
+          <a:ln w="6350">
+            <a:solidFill>
+              <a:srgbClr val="2A2A2A"/>
+            </a:solidFill>
+            <a:prstDash val="solid"/>
+          </a:ln>
+        </p:spPr>
+      </p:sp>
+      <p:pic>
+        <p:nvPicPr>
+          <p:cNvPr id="22" name="Image 0" descr="preencoded.png">    </p:cNvPr>
+          <p:cNvPicPr>
+            <a:picLocks noChangeAspect="1"/>
+          </p:cNvPicPr>
+          <p:nvPr/>
+        </p:nvPicPr>
+        <p:blipFill>
+          <a:blip r:embed="rId1"/>
+          <a:stretch>
+            <a:fillRect/>
+          </a:stretch>
+        </p:blipFill>
+        <p:spPr>
+          <a:xfrm>
+            <a:off x="5166360" y="1783080"/>
+            <a:ext cx="365760" cy="365760"/>
+          </a:xfrm>
+          <a:prstGeom prst="rect">
+            <a:avLst/>
+          </a:prstGeom>
+        </p:spPr>
+      </p:pic>
+      <p:sp>
+        <p:nvSpPr>
+          <p:cNvPr id="23" name="Text 20"/>
+          <p:cNvSpPr/>
+          <p:nvPr/>
+        </p:nvSpPr>
+        <p:spPr>
+          <a:xfrm>
+            <a:off x="5669280" y="1709928"/>
+            <a:ext cx="2743200" cy="274320"/>
+          </a:xfrm>
+          <a:prstGeom prst="rect">
+            <a:avLst/>
+          </a:prstGeom>
+          <a:noFill/>
+          <a:ln/>
+        </p:spPr>
+        <p:txBody>
+          <a:bodyPr wrap="square" lIns="0" tIns="0" rIns="0" bIns="0" rtlCol="0" anchor="ctr"/>
+          <a:lstStyle/>
+          <a:p>
+            <a:pPr indent="0" marL="0">
+              <a:buNone/>
+            </a:pPr>
+            <a:r>
+              <a:rPr lang="en-US" sz="1300" b="1" dirty="0">
+                <a:solidFill>
+                  <a:srgbClr val="FFFFFF"/>
+                </a:solidFill>
+                <a:latin typeface="Arial Black" pitchFamily="34" charset="0"/>
+                <a:ea typeface="Arial Black" pitchFamily="34" charset="-122"/>
+                <a:cs typeface="Arial Black" pitchFamily="34" charset="-120"/>
+              </a:rPr>
+              <a:t>Transferencia bancaria</a:t>
+            </a:r>
+            <a:endParaRPr lang="en-US" sz="1300" dirty="0"/>
+          </a:p>
+        </p:txBody>
+      </p:sp>
+      <p:sp>
+        <p:nvSpPr>
+          <p:cNvPr id="24" name="Text 21"/>
+          <p:cNvSpPr/>
+          <p:nvPr/>
+        </p:nvSpPr>
+        <p:spPr>
+          <a:xfrm>
+            <a:off x="5669280" y="1965960"/>
+            <a:ext cx="2743200" cy="228600"/>
+          </a:xfrm>
+          <a:prstGeom prst="rect">
+            <a:avLst/>
+          </a:prstGeom>
+          <a:noFill/>
+          <a:ln/>
+        </p:spPr>
+        <p:txBody>
+          <a:bodyPr wrap="square" lIns="0" tIns="0" rIns="0" bIns="0" rtlCol="0" anchor="ctr"/>
+          <a:lstStyle/>
+          <a:p>
+            <a:pPr indent="0" marL="0">
+              <a:buNone/>
+            </a:pPr>
+            <a:r>
+              <a:rPr lang="en-US" sz="1000" dirty="0">
+                <a:solidFill>
+                  <a:srgbClr val="B0B0B0"/>
+                </a:solidFill>
+                <a:latin typeface="Arial" pitchFamily="34" charset="0"/>
+                <a:ea typeface="Arial" pitchFamily="34" charset="-122"/>
+                <a:cs typeface="Arial" pitchFamily="34" charset="-120"/>
+              </a:rPr>
+              <a:t>Pesos argentinos (ARS) — CBU/alias</a:t>
+            </a:r>
+            <a:endParaRPr lang="en-US" sz="1000" dirty="0"/>
+          </a:p>
+        </p:txBody>
+      </p:sp>
+      <p:sp>
+        <p:nvSpPr>
+          <p:cNvPr id="25" name="Shape 22"/>
+          <p:cNvSpPr/>
+          <p:nvPr/>
+        </p:nvSpPr>
+        <p:spPr>
+          <a:xfrm>
+            <a:off x="5029200" y="2423160"/>
+            <a:ext cx="3566160" cy="548640"/>
+          </a:xfrm>
+          <a:prstGeom prst="rect">
+            <a:avLst/>
+          </a:prstGeom>
+          <a:solidFill>
+            <a:srgbClr val="1E1E1E"/>
+          </a:solidFill>
+          <a:ln w="6350">
+            <a:solidFill>
+              <a:srgbClr val="2A2A2A"/>
+            </a:solidFill>
+            <a:prstDash val="solid"/>
+          </a:ln>
+        </p:spPr>
+      </p:sp>
+      <p:pic>
+        <p:nvPicPr>
+          <p:cNvPr id="26" name="Image 1" descr="preencoded.png">    </p:cNvPr>
+          <p:cNvPicPr>
+            <a:picLocks noChangeAspect="1"/>
+          </p:cNvPicPr>
+          <p:nvPr/>
+        </p:nvPicPr>
+        <p:blipFill>
+          <a:blip r:embed="rId2"/>
+          <a:stretch>
+            <a:fillRect/>
+          </a:stretch>
+        </p:blipFill>
+        <p:spPr>
+          <a:xfrm>
+            <a:off x="5166360" y="2514600"/>
+            <a:ext cx="365760" cy="365760"/>
+          </a:xfrm>
+          <a:prstGeom prst="rect">
+            <a:avLst/>
+          </a:prstGeom>
+        </p:spPr>
+      </p:pic>
+      <p:sp>
+        <p:nvSpPr>
+          <p:cNvPr id="27" name="Text 23"/>
+          <p:cNvSpPr/>
+          <p:nvPr/>
+        </p:nvSpPr>
+        <p:spPr>
+          <a:xfrm>
+            <a:off x="5669280" y="2441448"/>
+            <a:ext cx="2743200" cy="274320"/>
+          </a:xfrm>
+          <a:prstGeom prst="rect">
+            <a:avLst/>
+          </a:prstGeom>
+          <a:noFill/>
+          <a:ln/>
+        </p:spPr>
+        <p:txBody>
+          <a:bodyPr wrap="square" lIns="0" tIns="0" rIns="0" bIns="0" rtlCol="0" anchor="ctr"/>
+          <a:lstStyle/>
+          <a:p>
+            <a:pPr indent="0" marL="0">
+              <a:buNone/>
+            </a:pPr>
+            <a:r>
+              <a:rPr lang="en-US" sz="1300" b="1" dirty="0">
+                <a:solidFill>
+                  <a:srgbClr val="FFFFFF"/>
+                </a:solidFill>
+                <a:latin typeface="Arial Black" pitchFamily="34" charset="0"/>
+                <a:ea typeface="Arial Black" pitchFamily="34" charset="-122"/>
+                <a:cs typeface="Arial Black" pitchFamily="34" charset="-120"/>
+              </a:rPr>
+              <a:t>MercadoPago</a:t>
+            </a:r>
+            <a:endParaRPr lang="en-US" sz="1300" dirty="0"/>
+          </a:p>
+        </p:txBody>
+      </p:sp>
+      <p:sp>
+        <p:nvSpPr>
+          <p:cNvPr id="28" name="Text 24"/>
+          <p:cNvSpPr/>
+          <p:nvPr/>
+        </p:nvSpPr>
+        <p:spPr>
+          <a:xfrm>
+            <a:off x="5669280" y="2697480"/>
+            <a:ext cx="2743200" cy="228600"/>
+          </a:xfrm>
+          <a:prstGeom prst="rect">
+            <a:avLst/>
+          </a:prstGeom>
+          <a:noFill/>
+          <a:ln/>
+        </p:spPr>
+        <p:txBody>
+          <a:bodyPr wrap="square" lIns="0" tIns="0" rIns="0" bIns="0" rtlCol="0" anchor="ctr"/>
+          <a:lstStyle/>
+          <a:p>
+            <a:pPr indent="0" marL="0">
+              <a:buNone/>
+            </a:pPr>
+            <a:r>
+              <a:rPr lang="en-US" sz="1000" dirty="0">
+                <a:solidFill>
+                  <a:srgbClr val="B0B0B0"/>
+                </a:solidFill>
+                <a:latin typeface="Arial" pitchFamily="34" charset="0"/>
+                <a:ea typeface="Arial" pitchFamily="34" charset="-122"/>
+                <a:cs typeface="Arial" pitchFamily="34" charset="-120"/>
+              </a:rPr>
+              <a:t>Tarjeta de crédito, débito o saldo MP</a:t>
+            </a:r>
+            <a:endParaRPr lang="en-US" sz="1000" dirty="0"/>
+          </a:p>
+        </p:txBody>
+      </p:sp>
+      <p:sp>
+        <p:nvSpPr>
+          <p:cNvPr id="29" name="Shape 25"/>
+          <p:cNvSpPr/>
+          <p:nvPr/>
+        </p:nvSpPr>
+        <p:spPr>
+          <a:xfrm>
+            <a:off x="457200" y="4572000"/>
+            <a:ext cx="8229600" cy="411480"/>
+          </a:xfrm>
+          <a:prstGeom prst="rect">
+            <a:avLst/>
+          </a:prstGeom>
+          <a:solidFill>
+            <a:srgbClr val="25D366">
+              <a:alpha val="15000"/>
+            </a:srgbClr>
+          </a:solidFill>
+          <a:ln w="12700">
+            <a:solidFill>
+              <a:srgbClr val="25D366"/>
+            </a:solidFill>
+            <a:prstDash val="solid"/>
+          </a:ln>
+        </p:spPr>
+      </p:sp>
+      <p:sp>
+        <p:nvSpPr>
+          <p:cNvPr id="30" name="Text 26"/>
+          <p:cNvSpPr/>
+          <p:nvPr/>
+        </p:nvSpPr>
+        <p:spPr>
+          <a:xfrm>
+            <a:off x="457200" y="4572000"/>
+            <a:ext cx="8229600" cy="411480"/>
+          </a:xfrm>
+          <a:prstGeom prst="rect">
+            <a:avLst/>
+          </a:prstGeom>
+          <a:noFill/>
+          <a:ln/>
+        </p:spPr>
+        <p:txBody>
+          <a:bodyPr wrap="square" lIns="0" tIns="0" rIns="0" bIns="0" rtlCol="0" anchor="ctr"/>
+          <a:lstStyle/>
+          <a:p>
+            <a:pPr algn="ctr" indent="0" marL="0">
+              <a:buNone/>
+            </a:pPr>
+            <a:r>
+              <a:rPr lang="en-US" sz="1300" b="1" dirty="0">
+                <a:solidFill>
+                  <a:srgbClr val="FFFFFF"/>
+                </a:solidFill>
+                <a:latin typeface="Arial Black" pitchFamily="34" charset="0"/>
+                <a:ea typeface="Arial Black" pitchFamily="34" charset="-122"/>
+                <a:cs typeface="Arial Black" pitchFamily="34" charset="-120"/>
+              </a:rPr>
+              <a:t>Garantía de satisfacción  •  Contrato claro  •  Sin letra chica</a:t>
+            </a:r>
+            <a:endParaRPr lang="en-US" sz="1300" dirty="0"/>
+          </a:p>
+        </p:txBody>
+      </p:sp>
+    </p:spTree>
+  </p:cSld>
+  <p:clrMapOvr>
+    <a:masterClrMapping/>
+  </p:clrMapOvr>
+</p:sld>
+</file>
+
+<file path=ppt/slides/slide13.xml><?xml version="1.0" encoding="utf-8"?>
+<p:sld xmlns:a="http://schemas.openxmlformats.org/drawingml/2006/main" xmlns:r="http://schemas.openxmlformats.org/officeDocument/2006/relationships" xmlns:p="http://schemas.openxmlformats.org/presentationml/2006/main">
+  <p:cSld name="Slide 13">
     <p:bg>
       <p:bgPr>
         <a:blipFill dpi="0" rotWithShape="1">
@@ -10008,7 +11069,7 @@
                 <a:ea typeface="Arial" pitchFamily="34" charset="-122"/>
                 <a:cs typeface="Arial" pitchFamily="34" charset="-120"/>
               </a:rPr>
-              <a:t>Reels y stories optimizados</a:t>
+              <a:t>Textos que generan consultas</a:t>
             </a:r>
             <a:endParaRPr lang="en-US" sz="1150" dirty="0"/>
           </a:p>
@@ -10071,7 +11132,7 @@
                 <a:ea typeface="Arial" pitchFamily="34" charset="-122"/>
                 <a:cs typeface="Arial" pitchFamily="34" charset="-120"/>
               </a:rPr>
-              <a:t>Textos que generan consultas</a:t>
+              <a:t>Adaptado a tu marca y estilo</a:t>
             </a:r>
             <a:endParaRPr lang="en-US" sz="1150" dirty="0"/>
           </a:p>
@@ -10134,7 +11195,7 @@
                 <a:ea typeface="Arial" pitchFamily="34" charset="-122"/>
                 <a:cs typeface="Arial" pitchFamily="34" charset="-120"/>
               </a:rPr>
-              <a:t>Adaptado a tu marca y estilo</a:t>
+              <a:t>Imágenes de alta calidad con IA</a:t>
             </a:r>
             <a:endParaRPr lang="en-US" sz="1150" dirty="0"/>
           </a:p>
@@ -11379,7 +12440,7 @@
                 <a:ea typeface="Arial" pitchFamily="34" charset="-122"/>
                 <a:cs typeface="Arial" pitchFamily="34" charset="-120"/>
               </a:rPr>
-              <a:t>Inversión mensual: ~$100 USD ≈ $120.000  →  </a:t>
+              <a:t>Inversión mensual: ~$200 USD ≈ $240.000  →  </a:t>
             </a:r>
             <a:pPr indent="0" marL="0">
               <a:buNone/>
@@ -11393,7 +12454,7 @@
                 <a:ea typeface="Arial" pitchFamily="34" charset="-122"/>
                 <a:cs typeface="Arial" pitchFamily="34" charset="-120"/>
               </a:rPr>
-              <a:t>ROI: 12x</a:t>
+              <a:t>ROI: 6x</a:t>
             </a:r>
             <a:endParaRPr lang="en-US" sz="1300" dirty="0"/>
           </a:p>

</xml_diff>